<commit_message>
feat: Add Supabase Authentication, public students database profile table, and forgot/register flows
</commit_message>
<xml_diff>
--- a/CampusMate_AI_Presentation.pptx
+++ b/CampusMate_AI_Presentation.pptx
@@ -5,14 +5,14 @@
     <p:sldMasterId id="2147483648" r:id="rId1"/>
   </p:sldMasterIdLst>
   <p:sldIdLst>
-    <p:sldId id="256" r:id="rId7"/>
-    <p:sldId id="257" r:id="rId8"/>
-    <p:sldId id="258" r:id="rId9"/>
-    <p:sldId id="259" r:id="rId10"/>
-    <p:sldId id="260" r:id="rId11"/>
-    <p:sldId id="261" r:id="rId12"/>
+    <p:sldId id="256" r:id="rId2"/>
+    <p:sldId id="257" r:id="rId3"/>
+    <p:sldId id="258" r:id="rId4"/>
+    <p:sldId id="259" r:id="rId5"/>
+    <p:sldId id="260" r:id="rId6"/>
+    <p:sldId id="261" r:id="rId7"/>
   </p:sldIdLst>
-  <p:sldSz cx="12191695" cy="6858000" type="screen4x3"/>
+  <p:sldSz cx="12192000" cy="6858000"/>
   <p:notesSz cx="6858000" cy="9144000"/>
   <p:defaultTextStyle>
     <a:defPPr>
@@ -109,6 +109,22 @@
       </a:defRPr>
     </a:lvl9pPr>
   </p:defaultTextStyle>
+  <p:extLst>
+    <p:ext uri="{EFAFB233-063F-42B5-8137-9DF3F51BA10A}">
+      <p15:sldGuideLst xmlns:p15="http://schemas.microsoft.com/office/powerpoint/2012/main">
+        <p15:guide id="1" orient="horz" pos="2160">
+          <p15:clr>
+            <a:srgbClr val="A4A3A4"/>
+          </p15:clr>
+        </p15:guide>
+        <p15:guide id="2" pos="2880">
+          <p15:clr>
+            <a:srgbClr val="A4A3A4"/>
+          </p15:clr>
+        </p15:guide>
+      </p15:sldGuideLst>
+    </p:ext>
+  </p:extLst>
 </p:presentation>
 </file>
 
@@ -150,10 +166,9 @@
           <a:lstStyle/>
           <a:p>
             <a:r>
-              <a:rPr lang="en-US" smtClean="0"/>
+              <a:rPr lang="en-US"/>
               <a:t>Click to edit Master title style</a:t>
             </a:r>
-            <a:endParaRPr lang="en-US"/>
           </a:p>
         </p:txBody>
       </p:sp>
@@ -269,10 +284,9 @@
           </a:lstStyle>
           <a:p>
             <a:r>
-              <a:rPr lang="en-US" smtClean="0"/>
+              <a:rPr lang="en-US"/>
               <a:t>Click to edit Master subtitle style</a:t>
             </a:r>
-            <a:endParaRPr lang="en-US"/>
           </a:p>
         </p:txBody>
       </p:sp>
@@ -293,7 +307,7 @@
           <a:p>
             <a:fld id="{5BCAD085-E8A6-8845-BD4E-CB4CCA059FC4}" type="datetimeFigureOut">
               <a:rPr lang="en-US" smtClean="0"/>
-              <a:t>1/27/13</a:t>
+              <a:t>8/12/2026</a:t>
             </a:fld>
             <a:endParaRPr lang="en-US"/>
           </a:p>
@@ -387,10 +401,9 @@
           <a:lstStyle/>
           <a:p>
             <a:r>
-              <a:rPr lang="en-US" smtClean="0"/>
+              <a:rPr lang="en-US"/>
               <a:t>Click to edit Master title style</a:t>
             </a:r>
-            <a:endParaRPr lang="en-US"/>
           </a:p>
         </p:txBody>
       </p:sp>
@@ -411,38 +424,37 @@
           <a:p>
             <a:pPr lvl="0"/>
             <a:r>
-              <a:rPr lang="en-US" smtClean="0"/>
+              <a:rPr lang="en-US"/>
               <a:t>Click to edit Master text styles</a:t>
             </a:r>
           </a:p>
           <a:p>
             <a:pPr lvl="1"/>
             <a:r>
-              <a:rPr lang="en-US" smtClean="0"/>
+              <a:rPr lang="en-US"/>
               <a:t>Second level</a:t>
             </a:r>
           </a:p>
           <a:p>
             <a:pPr lvl="2"/>
             <a:r>
-              <a:rPr lang="en-US" smtClean="0"/>
+              <a:rPr lang="en-US"/>
               <a:t>Third level</a:t>
             </a:r>
           </a:p>
           <a:p>
             <a:pPr lvl="3"/>
             <a:r>
-              <a:rPr lang="en-US" smtClean="0"/>
+              <a:rPr lang="en-US"/>
               <a:t>Fourth level</a:t>
             </a:r>
           </a:p>
           <a:p>
             <a:pPr lvl="4"/>
             <a:r>
-              <a:rPr lang="en-US" smtClean="0"/>
+              <a:rPr lang="en-US"/>
               <a:t>Fifth level</a:t>
             </a:r>
-            <a:endParaRPr lang="en-US"/>
           </a:p>
         </p:txBody>
       </p:sp>
@@ -463,7 +475,7 @@
           <a:p>
             <a:fld id="{5BCAD085-E8A6-8845-BD4E-CB4CCA059FC4}" type="datetimeFigureOut">
               <a:rPr lang="en-US" smtClean="0"/>
-              <a:t>1/27/13</a:t>
+              <a:t>8/12/2026</a:t>
             </a:fld>
             <a:endParaRPr lang="en-US"/>
           </a:p>
@@ -562,10 +574,9 @@
           <a:lstStyle/>
           <a:p>
             <a:r>
-              <a:rPr lang="en-US" smtClean="0"/>
+              <a:rPr lang="en-US"/>
               <a:t>Click to edit Master title style</a:t>
             </a:r>
-            <a:endParaRPr lang="en-US"/>
           </a:p>
         </p:txBody>
       </p:sp>
@@ -591,38 +602,37 @@
           <a:p>
             <a:pPr lvl="0"/>
             <a:r>
-              <a:rPr lang="en-US" smtClean="0"/>
+              <a:rPr lang="en-US"/>
               <a:t>Click to edit Master text styles</a:t>
             </a:r>
           </a:p>
           <a:p>
             <a:pPr lvl="1"/>
             <a:r>
-              <a:rPr lang="en-US" smtClean="0"/>
+              <a:rPr lang="en-US"/>
               <a:t>Second level</a:t>
             </a:r>
           </a:p>
           <a:p>
             <a:pPr lvl="2"/>
             <a:r>
-              <a:rPr lang="en-US" smtClean="0"/>
+              <a:rPr lang="en-US"/>
               <a:t>Third level</a:t>
             </a:r>
           </a:p>
           <a:p>
             <a:pPr lvl="3"/>
             <a:r>
-              <a:rPr lang="en-US" smtClean="0"/>
+              <a:rPr lang="en-US"/>
               <a:t>Fourth level</a:t>
             </a:r>
           </a:p>
           <a:p>
             <a:pPr lvl="4"/>
             <a:r>
-              <a:rPr lang="en-US" smtClean="0"/>
+              <a:rPr lang="en-US"/>
               <a:t>Fifth level</a:t>
             </a:r>
-            <a:endParaRPr lang="en-US"/>
           </a:p>
         </p:txBody>
       </p:sp>
@@ -643,7 +653,7 @@
           <a:p>
             <a:fld id="{5BCAD085-E8A6-8845-BD4E-CB4CCA059FC4}" type="datetimeFigureOut">
               <a:rPr lang="en-US" smtClean="0"/>
-              <a:t>1/27/13</a:t>
+              <a:t>8/12/2026</a:t>
             </a:fld>
             <a:endParaRPr lang="en-US"/>
           </a:p>
@@ -737,10 +747,9 @@
           <a:lstStyle/>
           <a:p>
             <a:r>
-              <a:rPr lang="en-US" smtClean="0"/>
+              <a:rPr lang="en-US"/>
               <a:t>Click to edit Master title style</a:t>
             </a:r>
-            <a:endParaRPr lang="en-US"/>
           </a:p>
         </p:txBody>
       </p:sp>
@@ -761,38 +770,37 @@
           <a:p>
             <a:pPr lvl="0"/>
             <a:r>
-              <a:rPr lang="en-US" smtClean="0"/>
+              <a:rPr lang="en-US"/>
               <a:t>Click to edit Master text styles</a:t>
             </a:r>
           </a:p>
           <a:p>
             <a:pPr lvl="1"/>
             <a:r>
-              <a:rPr lang="en-US" smtClean="0"/>
+              <a:rPr lang="en-US"/>
               <a:t>Second level</a:t>
             </a:r>
           </a:p>
           <a:p>
             <a:pPr lvl="2"/>
             <a:r>
-              <a:rPr lang="en-US" smtClean="0"/>
+              <a:rPr lang="en-US"/>
               <a:t>Third level</a:t>
             </a:r>
           </a:p>
           <a:p>
             <a:pPr lvl="3"/>
             <a:r>
-              <a:rPr lang="en-US" smtClean="0"/>
+              <a:rPr lang="en-US"/>
               <a:t>Fourth level</a:t>
             </a:r>
           </a:p>
           <a:p>
             <a:pPr lvl="4"/>
             <a:r>
-              <a:rPr lang="en-US" smtClean="0"/>
+              <a:rPr lang="en-US"/>
               <a:t>Fifth level</a:t>
             </a:r>
-            <a:endParaRPr lang="en-US"/>
           </a:p>
         </p:txBody>
       </p:sp>
@@ -813,7 +821,7 @@
           <a:p>
             <a:fld id="{5BCAD085-E8A6-8845-BD4E-CB4CCA059FC4}" type="datetimeFigureOut">
               <a:rPr lang="en-US" smtClean="0"/>
-              <a:t>1/27/13</a:t>
+              <a:t>8/12/2026</a:t>
             </a:fld>
             <a:endParaRPr lang="en-US"/>
           </a:p>
@@ -916,10 +924,9 @@
           </a:lstStyle>
           <a:p>
             <a:r>
-              <a:rPr lang="en-US" smtClean="0"/>
+              <a:rPr lang="en-US"/>
               <a:t>Click to edit Master title style</a:t>
             </a:r>
-            <a:endParaRPr lang="en-US"/>
           </a:p>
         </p:txBody>
       </p:sp>
@@ -1036,7 +1043,7 @@
           <a:p>
             <a:pPr lvl="0"/>
             <a:r>
-              <a:rPr lang="en-US" smtClean="0"/>
+              <a:rPr lang="en-US"/>
               <a:t>Click to edit Master text styles</a:t>
             </a:r>
           </a:p>
@@ -1059,7 +1066,7 @@
           <a:p>
             <a:fld id="{5BCAD085-E8A6-8845-BD4E-CB4CCA059FC4}" type="datetimeFigureOut">
               <a:rPr lang="en-US" smtClean="0"/>
-              <a:t>1/27/13</a:t>
+              <a:t>8/12/2026</a:t>
             </a:fld>
             <a:endParaRPr lang="en-US"/>
           </a:p>
@@ -1153,10 +1160,9 @@
           <a:lstStyle/>
           <a:p>
             <a:r>
-              <a:rPr lang="en-US" smtClean="0"/>
+              <a:rPr lang="en-US"/>
               <a:t>Click to edit Master title style</a:t>
             </a:r>
-            <a:endParaRPr lang="en-US"/>
           </a:p>
         </p:txBody>
       </p:sp>
@@ -1210,38 +1216,37 @@
           <a:p>
             <a:pPr lvl="0"/>
             <a:r>
-              <a:rPr lang="en-US" smtClean="0"/>
+              <a:rPr lang="en-US"/>
               <a:t>Click to edit Master text styles</a:t>
             </a:r>
           </a:p>
           <a:p>
             <a:pPr lvl="1"/>
             <a:r>
-              <a:rPr lang="en-US" smtClean="0"/>
+              <a:rPr lang="en-US"/>
               <a:t>Second level</a:t>
             </a:r>
           </a:p>
           <a:p>
             <a:pPr lvl="2"/>
             <a:r>
-              <a:rPr lang="en-US" smtClean="0"/>
+              <a:rPr lang="en-US"/>
               <a:t>Third level</a:t>
             </a:r>
           </a:p>
           <a:p>
             <a:pPr lvl="3"/>
             <a:r>
-              <a:rPr lang="en-US" smtClean="0"/>
+              <a:rPr lang="en-US"/>
               <a:t>Fourth level</a:t>
             </a:r>
           </a:p>
           <a:p>
             <a:pPr lvl="4"/>
             <a:r>
-              <a:rPr lang="en-US" smtClean="0"/>
+              <a:rPr lang="en-US"/>
               <a:t>Fifth level</a:t>
             </a:r>
-            <a:endParaRPr lang="en-US"/>
           </a:p>
         </p:txBody>
       </p:sp>
@@ -1295,38 +1300,37 @@
           <a:p>
             <a:pPr lvl="0"/>
             <a:r>
-              <a:rPr lang="en-US" smtClean="0"/>
+              <a:rPr lang="en-US"/>
               <a:t>Click to edit Master text styles</a:t>
             </a:r>
           </a:p>
           <a:p>
             <a:pPr lvl="1"/>
             <a:r>
-              <a:rPr lang="en-US" smtClean="0"/>
+              <a:rPr lang="en-US"/>
               <a:t>Second level</a:t>
             </a:r>
           </a:p>
           <a:p>
             <a:pPr lvl="2"/>
             <a:r>
-              <a:rPr lang="en-US" smtClean="0"/>
+              <a:rPr lang="en-US"/>
               <a:t>Third level</a:t>
             </a:r>
           </a:p>
           <a:p>
             <a:pPr lvl="3"/>
             <a:r>
-              <a:rPr lang="en-US" smtClean="0"/>
+              <a:rPr lang="en-US"/>
               <a:t>Fourth level</a:t>
             </a:r>
           </a:p>
           <a:p>
             <a:pPr lvl="4"/>
             <a:r>
-              <a:rPr lang="en-US" smtClean="0"/>
+              <a:rPr lang="en-US"/>
               <a:t>Fifth level</a:t>
             </a:r>
-            <a:endParaRPr lang="en-US"/>
           </a:p>
         </p:txBody>
       </p:sp>
@@ -1347,7 +1351,7 @@
           <a:p>
             <a:fld id="{5BCAD085-E8A6-8845-BD4E-CB4CCA059FC4}" type="datetimeFigureOut">
               <a:rPr lang="en-US" smtClean="0"/>
-              <a:t>1/27/13</a:t>
+              <a:t>8/12/2026</a:t>
             </a:fld>
             <a:endParaRPr lang="en-US"/>
           </a:p>
@@ -1445,10 +1449,9 @@
           </a:lstStyle>
           <a:p>
             <a:r>
-              <a:rPr lang="en-US" smtClean="0"/>
+              <a:rPr lang="en-US"/>
               <a:t>Click to edit Master title style</a:t>
             </a:r>
-            <a:endParaRPr lang="en-US"/>
           </a:p>
         </p:txBody>
       </p:sp>
@@ -1511,7 +1514,7 @@
           <a:p>
             <a:pPr lvl="0"/>
             <a:r>
-              <a:rPr lang="en-US" smtClean="0"/>
+              <a:rPr lang="en-US"/>
               <a:t>Click to edit Master text styles</a:t>
             </a:r>
           </a:p>
@@ -1567,38 +1570,37 @@
           <a:p>
             <a:pPr lvl="0"/>
             <a:r>
-              <a:rPr lang="en-US" smtClean="0"/>
+              <a:rPr lang="en-US"/>
               <a:t>Click to edit Master text styles</a:t>
             </a:r>
           </a:p>
           <a:p>
             <a:pPr lvl="1"/>
             <a:r>
-              <a:rPr lang="en-US" smtClean="0"/>
+              <a:rPr lang="en-US"/>
               <a:t>Second level</a:t>
             </a:r>
           </a:p>
           <a:p>
             <a:pPr lvl="2"/>
             <a:r>
-              <a:rPr lang="en-US" smtClean="0"/>
+              <a:rPr lang="en-US"/>
               <a:t>Third level</a:t>
             </a:r>
           </a:p>
           <a:p>
             <a:pPr lvl="3"/>
             <a:r>
-              <a:rPr lang="en-US" smtClean="0"/>
+              <a:rPr lang="en-US"/>
               <a:t>Fourth level</a:t>
             </a:r>
           </a:p>
           <a:p>
             <a:pPr lvl="4"/>
             <a:r>
-              <a:rPr lang="en-US" smtClean="0"/>
+              <a:rPr lang="en-US"/>
               <a:t>Fifth level</a:t>
             </a:r>
-            <a:endParaRPr lang="en-US"/>
           </a:p>
         </p:txBody>
       </p:sp>
@@ -1661,7 +1663,7 @@
           <a:p>
             <a:pPr lvl="0"/>
             <a:r>
-              <a:rPr lang="en-US" smtClean="0"/>
+              <a:rPr lang="en-US"/>
               <a:t>Click to edit Master text styles</a:t>
             </a:r>
           </a:p>
@@ -1717,38 +1719,37 @@
           <a:p>
             <a:pPr lvl="0"/>
             <a:r>
-              <a:rPr lang="en-US" smtClean="0"/>
+              <a:rPr lang="en-US"/>
               <a:t>Click to edit Master text styles</a:t>
             </a:r>
           </a:p>
           <a:p>
             <a:pPr lvl="1"/>
             <a:r>
-              <a:rPr lang="en-US" smtClean="0"/>
+              <a:rPr lang="en-US"/>
               <a:t>Second level</a:t>
             </a:r>
           </a:p>
           <a:p>
             <a:pPr lvl="2"/>
             <a:r>
-              <a:rPr lang="en-US" smtClean="0"/>
+              <a:rPr lang="en-US"/>
               <a:t>Third level</a:t>
             </a:r>
           </a:p>
           <a:p>
             <a:pPr lvl="3"/>
             <a:r>
-              <a:rPr lang="en-US" smtClean="0"/>
+              <a:rPr lang="en-US"/>
               <a:t>Fourth level</a:t>
             </a:r>
           </a:p>
           <a:p>
             <a:pPr lvl="4"/>
             <a:r>
-              <a:rPr lang="en-US" smtClean="0"/>
+              <a:rPr lang="en-US"/>
               <a:t>Fifth level</a:t>
             </a:r>
-            <a:endParaRPr lang="en-US"/>
           </a:p>
         </p:txBody>
       </p:sp>
@@ -1769,7 +1770,7 @@
           <a:p>
             <a:fld id="{5BCAD085-E8A6-8845-BD4E-CB4CCA059FC4}" type="datetimeFigureOut">
               <a:rPr lang="en-US" smtClean="0"/>
-              <a:t>1/27/13</a:t>
+              <a:t>8/12/2026</a:t>
             </a:fld>
             <a:endParaRPr lang="en-US"/>
           </a:p>
@@ -1863,10 +1864,9 @@
           <a:lstStyle/>
           <a:p>
             <a:r>
-              <a:rPr lang="en-US" smtClean="0"/>
+              <a:rPr lang="en-US"/>
               <a:t>Click to edit Master title style</a:t>
             </a:r>
-            <a:endParaRPr lang="en-US"/>
           </a:p>
         </p:txBody>
       </p:sp>
@@ -1887,7 +1887,7 @@
           <a:p>
             <a:fld id="{5BCAD085-E8A6-8845-BD4E-CB4CCA059FC4}" type="datetimeFigureOut">
               <a:rPr lang="en-US" smtClean="0"/>
-              <a:t>1/27/13</a:t>
+              <a:t>8/12/2026</a:t>
             </a:fld>
             <a:endParaRPr lang="en-US"/>
           </a:p>
@@ -1982,7 +1982,7 @@
           <a:p>
             <a:fld id="{5BCAD085-E8A6-8845-BD4E-CB4CCA059FC4}" type="datetimeFigureOut">
               <a:rPr lang="en-US" smtClean="0"/>
-              <a:t>1/27/13</a:t>
+              <a:t>8/12/2026</a:t>
             </a:fld>
             <a:endParaRPr lang="en-US"/>
           </a:p>
@@ -2085,10 +2085,9 @@
           </a:lstStyle>
           <a:p>
             <a:r>
-              <a:rPr lang="en-US" smtClean="0"/>
+              <a:rPr lang="en-US"/>
               <a:t>Click to edit Master title style</a:t>
             </a:r>
-            <a:endParaRPr lang="en-US"/>
           </a:p>
         </p:txBody>
       </p:sp>
@@ -2142,38 +2141,37 @@
           <a:p>
             <a:pPr lvl="0"/>
             <a:r>
-              <a:rPr lang="en-US" smtClean="0"/>
+              <a:rPr lang="en-US"/>
               <a:t>Click to edit Master text styles</a:t>
             </a:r>
           </a:p>
           <a:p>
             <a:pPr lvl="1"/>
             <a:r>
-              <a:rPr lang="en-US" smtClean="0"/>
+              <a:rPr lang="en-US"/>
               <a:t>Second level</a:t>
             </a:r>
           </a:p>
           <a:p>
             <a:pPr lvl="2"/>
             <a:r>
-              <a:rPr lang="en-US" smtClean="0"/>
+              <a:rPr lang="en-US"/>
               <a:t>Third level</a:t>
             </a:r>
           </a:p>
           <a:p>
             <a:pPr lvl="3"/>
             <a:r>
-              <a:rPr lang="en-US" smtClean="0"/>
+              <a:rPr lang="en-US"/>
               <a:t>Fourth level</a:t>
             </a:r>
           </a:p>
           <a:p>
             <a:pPr lvl="4"/>
             <a:r>
-              <a:rPr lang="en-US" smtClean="0"/>
+              <a:rPr lang="en-US"/>
               <a:t>Fifth level</a:t>
             </a:r>
-            <a:endParaRPr lang="en-US"/>
           </a:p>
         </p:txBody>
       </p:sp>
@@ -2236,7 +2234,7 @@
           <a:p>
             <a:pPr lvl="0"/>
             <a:r>
-              <a:rPr lang="en-US" smtClean="0"/>
+              <a:rPr lang="en-US"/>
               <a:t>Click to edit Master text styles</a:t>
             </a:r>
           </a:p>
@@ -2259,7 +2257,7 @@
           <a:p>
             <a:fld id="{5BCAD085-E8A6-8845-BD4E-CB4CCA059FC4}" type="datetimeFigureOut">
               <a:rPr lang="en-US" smtClean="0"/>
-              <a:t>1/27/13</a:t>
+              <a:t>8/12/2026</a:t>
             </a:fld>
             <a:endParaRPr lang="en-US"/>
           </a:p>
@@ -2362,10 +2360,9 @@
           </a:lstStyle>
           <a:p>
             <a:r>
-              <a:rPr lang="en-US" smtClean="0"/>
+              <a:rPr lang="en-US"/>
               <a:t>Click to edit Master title style</a:t>
             </a:r>
-            <a:endParaRPr lang="en-US"/>
           </a:p>
         </p:txBody>
       </p:sp>
@@ -2489,7 +2486,7 @@
           <a:p>
             <a:pPr lvl="0"/>
             <a:r>
-              <a:rPr lang="en-US" smtClean="0"/>
+              <a:rPr lang="en-US"/>
               <a:t>Click to edit Master text styles</a:t>
             </a:r>
           </a:p>
@@ -2512,7 +2509,7 @@
           <a:p>
             <a:fld id="{5BCAD085-E8A6-8845-BD4E-CB4CCA059FC4}" type="datetimeFigureOut">
               <a:rPr lang="en-US" smtClean="0"/>
-              <a:t>1/27/13</a:t>
+              <a:t>8/12/2026</a:t>
             </a:fld>
             <a:endParaRPr lang="en-US"/>
           </a:p>
@@ -2621,10 +2618,9 @@
           <a:lstStyle/>
           <a:p>
             <a:r>
-              <a:rPr lang="en-US" smtClean="0"/>
+              <a:rPr lang="en-US"/>
               <a:t>Click to edit Master title style</a:t>
             </a:r>
-            <a:endParaRPr lang="en-US"/>
           </a:p>
         </p:txBody>
       </p:sp>
@@ -2655,38 +2651,37 @@
           <a:p>
             <a:pPr lvl="0"/>
             <a:r>
-              <a:rPr lang="en-US" smtClean="0"/>
+              <a:rPr lang="en-US"/>
               <a:t>Click to edit Master text styles</a:t>
             </a:r>
           </a:p>
           <a:p>
             <a:pPr lvl="1"/>
             <a:r>
-              <a:rPr lang="en-US" smtClean="0"/>
+              <a:rPr lang="en-US"/>
               <a:t>Second level</a:t>
             </a:r>
           </a:p>
           <a:p>
             <a:pPr lvl="2"/>
             <a:r>
-              <a:rPr lang="en-US" smtClean="0"/>
+              <a:rPr lang="en-US"/>
               <a:t>Third level</a:t>
             </a:r>
           </a:p>
           <a:p>
             <a:pPr lvl="3"/>
             <a:r>
-              <a:rPr lang="en-US" smtClean="0"/>
+              <a:rPr lang="en-US"/>
               <a:t>Fourth level</a:t>
             </a:r>
           </a:p>
           <a:p>
             <a:pPr lvl="4"/>
             <a:r>
-              <a:rPr lang="en-US" smtClean="0"/>
+              <a:rPr lang="en-US"/>
               <a:t>Fifth level</a:t>
             </a:r>
-            <a:endParaRPr lang="en-US"/>
           </a:p>
         </p:txBody>
       </p:sp>
@@ -2725,7 +2720,7 @@
           <a:p>
             <a:fld id="{5BCAD085-E8A6-8845-BD4E-CB4CCA059FC4}" type="datetimeFigureOut">
               <a:rPr lang="en-US" smtClean="0"/>
-              <a:t>1/27/13</a:t>
+              <a:t>8/12/2026</a:t>
             </a:fld>
             <a:endParaRPr lang="en-US"/>
           </a:p>
@@ -3084,7 +3079,7 @@
 </file>
 
 <file path=ppt/slides/slide1.xml><?xml version="1.0" encoding="utf-8"?>
-<p:sld xmlns:a="http://schemas.openxmlformats.org/drawingml/2006/main" xmlns:p="http://schemas.openxmlformats.org/presentationml/2006/main" xmlns:r="http://schemas.openxmlformats.org/officeDocument/2006/relationships">
+<p:sld xmlns:a="http://schemas.openxmlformats.org/drawingml/2006/main" xmlns:r="http://schemas.openxmlformats.org/officeDocument/2006/relationships" xmlns:p="http://schemas.openxmlformats.org/presentationml/2006/main">
   <p:cSld>
     <p:bg>
       <p:bgPr>
@@ -3100,7 +3095,14 @@
         <p:cNvGrpSpPr/>
         <p:nvPr/>
       </p:nvGrpSpPr>
-      <p:grpSpPr/>
+      <p:grpSpPr>
+        <a:xfrm>
+          <a:off x="0" y="0"/>
+          <a:ext cx="0" cy="0"/>
+          <a:chOff x="0" y="0"/>
+          <a:chExt cx="0" cy="0"/>
+        </a:xfrm>
+      </p:grpSpPr>
       <p:sp>
         <p:nvSpPr>
           <p:cNvPr id="2" name="Rounded Rectangle 1"/>
@@ -3143,6 +3145,7 @@
           <a:lstStyle/>
           <a:p>
             <a:pPr algn="ctr"/>
+            <a:endParaRPr/>
           </a:p>
         </p:txBody>
       </p:sp>
@@ -3277,6 +3280,7 @@
           <a:lstStyle/>
           <a:p>
             <a:pPr algn="ctr"/>
+            <a:endParaRPr/>
           </a:p>
         </p:txBody>
       </p:sp>
@@ -3361,6 +3365,7 @@
           <a:lstStyle/>
           <a:p>
             <a:pPr algn="ctr"/>
+            <a:endParaRPr/>
           </a:p>
         </p:txBody>
       </p:sp>
@@ -3572,7 +3577,7 @@
 </file>
 
 <file path=ppt/slides/slide2.xml><?xml version="1.0" encoding="utf-8"?>
-<p:sld xmlns:a="http://schemas.openxmlformats.org/drawingml/2006/main" xmlns:p="http://schemas.openxmlformats.org/presentationml/2006/main" xmlns:r="http://schemas.openxmlformats.org/officeDocument/2006/relationships">
+<p:sld xmlns:a="http://schemas.openxmlformats.org/drawingml/2006/main" xmlns:r="http://schemas.openxmlformats.org/officeDocument/2006/relationships" xmlns:p="http://schemas.openxmlformats.org/presentationml/2006/main">
   <p:cSld>
     <p:bg>
       <p:bgPr>
@@ -3588,7 +3593,14 @@
         <p:cNvGrpSpPr/>
         <p:nvPr/>
       </p:nvGrpSpPr>
-      <p:grpSpPr/>
+      <p:grpSpPr>
+        <a:xfrm>
+          <a:off x="0" y="0"/>
+          <a:ext cx="0" cy="0"/>
+          <a:chOff x="0" y="0"/>
+          <a:chExt cx="0" cy="0"/>
+        </a:xfrm>
+      </p:grpSpPr>
       <p:sp>
         <p:nvSpPr>
           <p:cNvPr id="2" name="Rounded Rectangle 1"/>
@@ -3631,6 +3643,7 @@
           <a:lstStyle/>
           <a:p>
             <a:pPr algn="ctr"/>
+            <a:endParaRPr/>
           </a:p>
         </p:txBody>
       </p:sp>
@@ -3748,6 +3761,7 @@
           <a:lstStyle/>
           <a:p>
             <a:pPr algn="ctr"/>
+            <a:endParaRPr/>
           </a:p>
         </p:txBody>
       </p:sp>
@@ -3896,6 +3910,7 @@
           <a:lstStyle/>
           <a:p>
             <a:pPr algn="ctr"/>
+            <a:endParaRPr/>
           </a:p>
         </p:txBody>
       </p:sp>
@@ -4035,7 +4050,7 @@
 </file>
 
 <file path=ppt/slides/slide3.xml><?xml version="1.0" encoding="utf-8"?>
-<p:sld xmlns:a="http://schemas.openxmlformats.org/drawingml/2006/main" xmlns:p="http://schemas.openxmlformats.org/presentationml/2006/main" xmlns:r="http://schemas.openxmlformats.org/officeDocument/2006/relationships">
+<p:sld xmlns:a="http://schemas.openxmlformats.org/drawingml/2006/main" xmlns:r="http://schemas.openxmlformats.org/officeDocument/2006/relationships" xmlns:p="http://schemas.openxmlformats.org/presentationml/2006/main">
   <p:cSld>
     <p:bg>
       <p:bgPr>
@@ -4051,7 +4066,14 @@
         <p:cNvGrpSpPr/>
         <p:nvPr/>
       </p:nvGrpSpPr>
-      <p:grpSpPr/>
+      <p:grpSpPr>
+        <a:xfrm>
+          <a:off x="0" y="0"/>
+          <a:ext cx="0" cy="0"/>
+          <a:chOff x="0" y="0"/>
+          <a:chExt cx="0" cy="0"/>
+        </a:xfrm>
+      </p:grpSpPr>
       <p:sp>
         <p:nvSpPr>
           <p:cNvPr id="2" name="Rounded Rectangle 1"/>
@@ -4094,6 +4116,7 @@
           <a:lstStyle/>
           <a:p>
             <a:pPr algn="ctr"/>
+            <a:endParaRPr/>
           </a:p>
         </p:txBody>
       </p:sp>
@@ -4209,6 +4232,7 @@
           <a:lstStyle/>
           <a:p>
             <a:pPr algn="ctr"/>
+            <a:endParaRPr/>
           </a:p>
         </p:txBody>
       </p:sp>
@@ -4309,6 +4333,7 @@
           <a:lstStyle/>
           <a:p>
             <a:pPr algn="ctr"/>
+            <a:endParaRPr/>
           </a:p>
         </p:txBody>
       </p:sp>
@@ -4441,6 +4466,7 @@
           <a:lstStyle/>
           <a:p>
             <a:pPr algn="ctr"/>
+            <a:endParaRPr/>
           </a:p>
         </p:txBody>
       </p:sp>
@@ -4557,6 +4583,7 @@
           <a:lstStyle/>
           <a:p>
             <a:pPr algn="ctr"/>
+            <a:endParaRPr/>
           </a:p>
         </p:txBody>
       </p:sp>
@@ -4689,6 +4716,7 @@
           <a:lstStyle/>
           <a:p>
             <a:pPr algn="ctr"/>
+            <a:endParaRPr/>
           </a:p>
         </p:txBody>
       </p:sp>
@@ -4900,7 +4928,7 @@
 </file>
 
 <file path=ppt/slides/slide4.xml><?xml version="1.0" encoding="utf-8"?>
-<p:sld xmlns:a="http://schemas.openxmlformats.org/drawingml/2006/main" xmlns:p="http://schemas.openxmlformats.org/presentationml/2006/main" xmlns:r="http://schemas.openxmlformats.org/officeDocument/2006/relationships">
+<p:sld xmlns:a="http://schemas.openxmlformats.org/drawingml/2006/main" xmlns:r="http://schemas.openxmlformats.org/officeDocument/2006/relationships" xmlns:p="http://schemas.openxmlformats.org/presentationml/2006/main">
   <p:cSld>
     <p:bg>
       <p:bgPr>
@@ -4916,7 +4944,14 @@
         <p:cNvGrpSpPr/>
         <p:nvPr/>
       </p:nvGrpSpPr>
-      <p:grpSpPr/>
+      <p:grpSpPr>
+        <a:xfrm>
+          <a:off x="0" y="0"/>
+          <a:ext cx="0" cy="0"/>
+          <a:chOff x="0" y="0"/>
+          <a:chExt cx="0" cy="0"/>
+        </a:xfrm>
+      </p:grpSpPr>
       <p:sp>
         <p:nvSpPr>
           <p:cNvPr id="2" name="Rounded Rectangle 1"/>
@@ -4959,6 +4994,7 @@
           <a:lstStyle/>
           <a:p>
             <a:pPr algn="ctr"/>
+            <a:endParaRPr/>
           </a:p>
         </p:txBody>
       </p:sp>
@@ -5076,6 +5112,7 @@
           <a:lstStyle/>
           <a:p>
             <a:pPr algn="ctr"/>
+            <a:endParaRPr/>
           </a:p>
         </p:txBody>
       </p:sp>
@@ -5280,6 +5317,7 @@
           <a:lstStyle/>
           <a:p>
             <a:pPr algn="ctr"/>
+            <a:endParaRPr/>
           </a:p>
         </p:txBody>
       </p:sp>
@@ -5475,7 +5513,7 @@
 </file>
 
 <file path=ppt/slides/slide5.xml><?xml version="1.0" encoding="utf-8"?>
-<p:sld xmlns:a="http://schemas.openxmlformats.org/drawingml/2006/main" xmlns:p="http://schemas.openxmlformats.org/presentationml/2006/main" xmlns:r="http://schemas.openxmlformats.org/officeDocument/2006/relationships">
+<p:sld xmlns:a="http://schemas.openxmlformats.org/drawingml/2006/main" xmlns:r="http://schemas.openxmlformats.org/officeDocument/2006/relationships" xmlns:p="http://schemas.openxmlformats.org/presentationml/2006/main">
   <p:cSld>
     <p:bg>
       <p:bgPr>
@@ -5491,7 +5529,14 @@
         <p:cNvGrpSpPr/>
         <p:nvPr/>
       </p:nvGrpSpPr>
-      <p:grpSpPr/>
+      <p:grpSpPr>
+        <a:xfrm>
+          <a:off x="0" y="0"/>
+          <a:ext cx="0" cy="0"/>
+          <a:chOff x="0" y="0"/>
+          <a:chExt cx="0" cy="0"/>
+        </a:xfrm>
+      </p:grpSpPr>
       <p:sp>
         <p:nvSpPr>
           <p:cNvPr id="2" name="Rounded Rectangle 1"/>
@@ -5534,6 +5579,7 @@
           <a:lstStyle/>
           <a:p>
             <a:pPr algn="ctr"/>
+            <a:endParaRPr/>
           </a:p>
         </p:txBody>
       </p:sp>
@@ -5651,6 +5697,7 @@
           <a:lstStyle/>
           <a:p>
             <a:pPr algn="ctr"/>
+            <a:endParaRPr/>
           </a:p>
         </p:txBody>
       </p:sp>
@@ -5887,6 +5934,7 @@
           <a:lstStyle/>
           <a:p>
             <a:pPr algn="ctr"/>
+            <a:endParaRPr/>
           </a:p>
         </p:txBody>
       </p:sp>
@@ -5948,10 +5996,34 @@
                 <a:tableStyleId>{5C22544A-7EE6-4342-B048-85BDC9FD1C3A}</a:tableStyleId>
               </a:tblPr>
               <a:tblGrid>
-                <a:gridCol w="1257300"/>
-                <a:gridCol w="1257300"/>
-                <a:gridCol w="1257300"/>
-                <a:gridCol w="1257300"/>
+                <a:gridCol w="1257300">
+                  <a:extLst>
+                    <a:ext uri="{9D8B030D-6E8A-4147-A177-3AD203B41FA5}">
+                      <a16:colId xmlns:a16="http://schemas.microsoft.com/office/drawing/2014/main" val="20000"/>
+                    </a:ext>
+                  </a:extLst>
+                </a:gridCol>
+                <a:gridCol w="1257300">
+                  <a:extLst>
+                    <a:ext uri="{9D8B030D-6E8A-4147-A177-3AD203B41FA5}">
+                      <a16:colId xmlns:a16="http://schemas.microsoft.com/office/drawing/2014/main" val="20001"/>
+                    </a:ext>
+                  </a:extLst>
+                </a:gridCol>
+                <a:gridCol w="1257300">
+                  <a:extLst>
+                    <a:ext uri="{9D8B030D-6E8A-4147-A177-3AD203B41FA5}">
+                      <a16:colId xmlns:a16="http://schemas.microsoft.com/office/drawing/2014/main" val="20002"/>
+                    </a:ext>
+                  </a:extLst>
+                </a:gridCol>
+                <a:gridCol w="1257300">
+                  <a:extLst>
+                    <a:ext uri="{9D8B030D-6E8A-4147-A177-3AD203B41FA5}">
+                      <a16:colId xmlns:a16="http://schemas.microsoft.com/office/drawing/2014/main" val="20003"/>
+                    </a:ext>
+                  </a:extLst>
+                </a:gridCol>
               </a:tblGrid>
               <a:tr h="548640">
                 <a:tc>
@@ -6050,6 +6122,11 @@
                     </a:solidFill>
                   </a:tcPr>
                 </a:tc>
+                <a:extLst>
+                  <a:ext uri="{0D108BD9-81ED-4DB2-BD59-A6C34878D82A}">
+                    <a16:rowId xmlns:a16="http://schemas.microsoft.com/office/drawing/2014/main" val="10000"/>
+                  </a:ext>
+                </a:extLst>
               </a:tr>
               <a:tr h="548640">
                 <a:tc>
@@ -6148,6 +6225,11 @@
                     </a:solidFill>
                   </a:tcPr>
                 </a:tc>
+                <a:extLst>
+                  <a:ext uri="{0D108BD9-81ED-4DB2-BD59-A6C34878D82A}">
+                    <a16:rowId xmlns:a16="http://schemas.microsoft.com/office/drawing/2014/main" val="10001"/>
+                  </a:ext>
+                </a:extLst>
               </a:tr>
               <a:tr h="548640">
                 <a:tc>
@@ -6246,6 +6328,11 @@
                     </a:solidFill>
                   </a:tcPr>
                 </a:tc>
+                <a:extLst>
+                  <a:ext uri="{0D108BD9-81ED-4DB2-BD59-A6C34878D82A}">
+                    <a16:rowId xmlns:a16="http://schemas.microsoft.com/office/drawing/2014/main" val="10002"/>
+                  </a:ext>
+                </a:extLst>
               </a:tr>
               <a:tr h="548640">
                 <a:tc>
@@ -6344,6 +6431,11 @@
                     </a:solidFill>
                   </a:tcPr>
                 </a:tc>
+                <a:extLst>
+                  <a:ext uri="{0D108BD9-81ED-4DB2-BD59-A6C34878D82A}">
+                    <a16:rowId xmlns:a16="http://schemas.microsoft.com/office/drawing/2014/main" val="10003"/>
+                  </a:ext>
+                </a:extLst>
               </a:tr>
               <a:tr h="548640">
                 <a:tc>
@@ -6442,6 +6534,11 @@
                     </a:solidFill>
                   </a:tcPr>
                 </a:tc>
+                <a:extLst>
+                  <a:ext uri="{0D108BD9-81ED-4DB2-BD59-A6C34878D82A}">
+                    <a16:rowId xmlns:a16="http://schemas.microsoft.com/office/drawing/2014/main" val="10004"/>
+                  </a:ext>
+                </a:extLst>
               </a:tr>
               <a:tr h="548640">
                 <a:tc>
@@ -6540,6 +6637,11 @@
                     </a:solidFill>
                   </a:tcPr>
                 </a:tc>
+                <a:extLst>
+                  <a:ext uri="{0D108BD9-81ED-4DB2-BD59-A6C34878D82A}">
+                    <a16:rowId xmlns:a16="http://schemas.microsoft.com/office/drawing/2014/main" val="10005"/>
+                  </a:ext>
+                </a:extLst>
               </a:tr>
               <a:tr h="548640">
                 <a:tc>
@@ -6638,6 +6740,11 @@
                     </a:solidFill>
                   </a:tcPr>
                 </a:tc>
+                <a:extLst>
+                  <a:ext uri="{0D108BD9-81ED-4DB2-BD59-A6C34878D82A}">
+                    <a16:rowId xmlns:a16="http://schemas.microsoft.com/office/drawing/2014/main" val="10006"/>
+                  </a:ext>
+                </a:extLst>
               </a:tr>
             </a:tbl>
           </a:graphicData>
@@ -6652,7 +6759,7 @@
 </file>
 
 <file path=ppt/slides/slide6.xml><?xml version="1.0" encoding="utf-8"?>
-<p:sld xmlns:a="http://schemas.openxmlformats.org/drawingml/2006/main" xmlns:p="http://schemas.openxmlformats.org/presentationml/2006/main" xmlns:r="http://schemas.openxmlformats.org/officeDocument/2006/relationships">
+<p:sld xmlns:a="http://schemas.openxmlformats.org/drawingml/2006/main" xmlns:r="http://schemas.openxmlformats.org/officeDocument/2006/relationships" xmlns:p="http://schemas.openxmlformats.org/presentationml/2006/main">
   <p:cSld>
     <p:bg>
       <p:bgPr>
@@ -6668,7 +6775,14 @@
         <p:cNvGrpSpPr/>
         <p:nvPr/>
       </p:nvGrpSpPr>
-      <p:grpSpPr/>
+      <p:grpSpPr>
+        <a:xfrm>
+          <a:off x="0" y="0"/>
+          <a:ext cx="0" cy="0"/>
+          <a:chOff x="0" y="0"/>
+          <a:chExt cx="0" cy="0"/>
+        </a:xfrm>
+      </p:grpSpPr>
       <p:sp>
         <p:nvSpPr>
           <p:cNvPr id="2" name="Rounded Rectangle 1"/>
@@ -6711,6 +6825,7 @@
           <a:lstStyle/>
           <a:p>
             <a:pPr algn="ctr"/>
+            <a:endParaRPr/>
           </a:p>
         </p:txBody>
       </p:sp>
@@ -6828,6 +6943,7 @@
           <a:lstStyle/>
           <a:p>
             <a:pPr algn="ctr"/>
+            <a:endParaRPr/>
           </a:p>
         </p:txBody>
       </p:sp>
@@ -7056,6 +7172,7 @@
           <a:lstStyle/>
           <a:p>
             <a:pPr algn="ctr"/>
+            <a:endParaRPr/>
           </a:p>
         </p:txBody>
       </p:sp>

</xml_diff>

<commit_message>
revert: Restore original working version (pre-database integration)
</commit_message>
<xml_diff>
--- a/CampusMate_AI_Presentation.pptx
+++ b/CampusMate_AI_Presentation.pptx
@@ -5,14 +5,14 @@
     <p:sldMasterId id="2147483648" r:id="rId1"/>
   </p:sldMasterIdLst>
   <p:sldIdLst>
-    <p:sldId id="256" r:id="rId2"/>
-    <p:sldId id="257" r:id="rId3"/>
-    <p:sldId id="258" r:id="rId4"/>
-    <p:sldId id="259" r:id="rId5"/>
-    <p:sldId id="260" r:id="rId6"/>
-    <p:sldId id="261" r:id="rId7"/>
+    <p:sldId id="256" r:id="rId7"/>
+    <p:sldId id="257" r:id="rId8"/>
+    <p:sldId id="258" r:id="rId9"/>
+    <p:sldId id="259" r:id="rId10"/>
+    <p:sldId id="260" r:id="rId11"/>
+    <p:sldId id="261" r:id="rId12"/>
   </p:sldIdLst>
-  <p:sldSz cx="12192000" cy="6858000"/>
+  <p:sldSz cx="12191695" cy="6858000" type="screen4x3"/>
   <p:notesSz cx="6858000" cy="9144000"/>
   <p:defaultTextStyle>
     <a:defPPr>
@@ -109,22 +109,6 @@
       </a:defRPr>
     </a:lvl9pPr>
   </p:defaultTextStyle>
-  <p:extLst>
-    <p:ext uri="{EFAFB233-063F-42B5-8137-9DF3F51BA10A}">
-      <p15:sldGuideLst xmlns:p15="http://schemas.microsoft.com/office/powerpoint/2012/main">
-        <p15:guide id="1" orient="horz" pos="2160">
-          <p15:clr>
-            <a:srgbClr val="A4A3A4"/>
-          </p15:clr>
-        </p15:guide>
-        <p15:guide id="2" pos="2880">
-          <p15:clr>
-            <a:srgbClr val="A4A3A4"/>
-          </p15:clr>
-        </p15:guide>
-      </p15:sldGuideLst>
-    </p:ext>
-  </p:extLst>
 </p:presentation>
 </file>
 
@@ -166,9 +150,10 @@
           <a:lstStyle/>
           <a:p>
             <a:r>
-              <a:rPr lang="en-US"/>
+              <a:rPr lang="en-US" smtClean="0"/>
               <a:t>Click to edit Master title style</a:t>
             </a:r>
+            <a:endParaRPr lang="en-US"/>
           </a:p>
         </p:txBody>
       </p:sp>
@@ -284,9 +269,10 @@
           </a:lstStyle>
           <a:p>
             <a:r>
-              <a:rPr lang="en-US"/>
+              <a:rPr lang="en-US" smtClean="0"/>
               <a:t>Click to edit Master subtitle style</a:t>
             </a:r>
+            <a:endParaRPr lang="en-US"/>
           </a:p>
         </p:txBody>
       </p:sp>
@@ -307,7 +293,7 @@
           <a:p>
             <a:fld id="{5BCAD085-E8A6-8845-BD4E-CB4CCA059FC4}" type="datetimeFigureOut">
               <a:rPr lang="en-US" smtClean="0"/>
-              <a:t>8/12/2026</a:t>
+              <a:t>1/27/13</a:t>
             </a:fld>
             <a:endParaRPr lang="en-US"/>
           </a:p>
@@ -401,9 +387,10 @@
           <a:lstStyle/>
           <a:p>
             <a:r>
-              <a:rPr lang="en-US"/>
+              <a:rPr lang="en-US" smtClean="0"/>
               <a:t>Click to edit Master title style</a:t>
             </a:r>
+            <a:endParaRPr lang="en-US"/>
           </a:p>
         </p:txBody>
       </p:sp>
@@ -424,37 +411,38 @@
           <a:p>
             <a:pPr lvl="0"/>
             <a:r>
-              <a:rPr lang="en-US"/>
+              <a:rPr lang="en-US" smtClean="0"/>
               <a:t>Click to edit Master text styles</a:t>
             </a:r>
           </a:p>
           <a:p>
             <a:pPr lvl="1"/>
             <a:r>
-              <a:rPr lang="en-US"/>
+              <a:rPr lang="en-US" smtClean="0"/>
               <a:t>Second level</a:t>
             </a:r>
           </a:p>
           <a:p>
             <a:pPr lvl="2"/>
             <a:r>
-              <a:rPr lang="en-US"/>
+              <a:rPr lang="en-US" smtClean="0"/>
               <a:t>Third level</a:t>
             </a:r>
           </a:p>
           <a:p>
             <a:pPr lvl="3"/>
             <a:r>
-              <a:rPr lang="en-US"/>
+              <a:rPr lang="en-US" smtClean="0"/>
               <a:t>Fourth level</a:t>
             </a:r>
           </a:p>
           <a:p>
             <a:pPr lvl="4"/>
             <a:r>
-              <a:rPr lang="en-US"/>
+              <a:rPr lang="en-US" smtClean="0"/>
               <a:t>Fifth level</a:t>
             </a:r>
+            <a:endParaRPr lang="en-US"/>
           </a:p>
         </p:txBody>
       </p:sp>
@@ -475,7 +463,7 @@
           <a:p>
             <a:fld id="{5BCAD085-E8A6-8845-BD4E-CB4CCA059FC4}" type="datetimeFigureOut">
               <a:rPr lang="en-US" smtClean="0"/>
-              <a:t>8/12/2026</a:t>
+              <a:t>1/27/13</a:t>
             </a:fld>
             <a:endParaRPr lang="en-US"/>
           </a:p>
@@ -574,9 +562,10 @@
           <a:lstStyle/>
           <a:p>
             <a:r>
-              <a:rPr lang="en-US"/>
+              <a:rPr lang="en-US" smtClean="0"/>
               <a:t>Click to edit Master title style</a:t>
             </a:r>
+            <a:endParaRPr lang="en-US"/>
           </a:p>
         </p:txBody>
       </p:sp>
@@ -602,37 +591,38 @@
           <a:p>
             <a:pPr lvl="0"/>
             <a:r>
-              <a:rPr lang="en-US"/>
+              <a:rPr lang="en-US" smtClean="0"/>
               <a:t>Click to edit Master text styles</a:t>
             </a:r>
           </a:p>
           <a:p>
             <a:pPr lvl="1"/>
             <a:r>
-              <a:rPr lang="en-US"/>
+              <a:rPr lang="en-US" smtClean="0"/>
               <a:t>Second level</a:t>
             </a:r>
           </a:p>
           <a:p>
             <a:pPr lvl="2"/>
             <a:r>
-              <a:rPr lang="en-US"/>
+              <a:rPr lang="en-US" smtClean="0"/>
               <a:t>Third level</a:t>
             </a:r>
           </a:p>
           <a:p>
             <a:pPr lvl="3"/>
             <a:r>
-              <a:rPr lang="en-US"/>
+              <a:rPr lang="en-US" smtClean="0"/>
               <a:t>Fourth level</a:t>
             </a:r>
           </a:p>
           <a:p>
             <a:pPr lvl="4"/>
             <a:r>
-              <a:rPr lang="en-US"/>
+              <a:rPr lang="en-US" smtClean="0"/>
               <a:t>Fifth level</a:t>
             </a:r>
+            <a:endParaRPr lang="en-US"/>
           </a:p>
         </p:txBody>
       </p:sp>
@@ -653,7 +643,7 @@
           <a:p>
             <a:fld id="{5BCAD085-E8A6-8845-BD4E-CB4CCA059FC4}" type="datetimeFigureOut">
               <a:rPr lang="en-US" smtClean="0"/>
-              <a:t>8/12/2026</a:t>
+              <a:t>1/27/13</a:t>
             </a:fld>
             <a:endParaRPr lang="en-US"/>
           </a:p>
@@ -747,9 +737,10 @@
           <a:lstStyle/>
           <a:p>
             <a:r>
-              <a:rPr lang="en-US"/>
+              <a:rPr lang="en-US" smtClean="0"/>
               <a:t>Click to edit Master title style</a:t>
             </a:r>
+            <a:endParaRPr lang="en-US"/>
           </a:p>
         </p:txBody>
       </p:sp>
@@ -770,37 +761,38 @@
           <a:p>
             <a:pPr lvl="0"/>
             <a:r>
-              <a:rPr lang="en-US"/>
+              <a:rPr lang="en-US" smtClean="0"/>
               <a:t>Click to edit Master text styles</a:t>
             </a:r>
           </a:p>
           <a:p>
             <a:pPr lvl="1"/>
             <a:r>
-              <a:rPr lang="en-US"/>
+              <a:rPr lang="en-US" smtClean="0"/>
               <a:t>Second level</a:t>
             </a:r>
           </a:p>
           <a:p>
             <a:pPr lvl="2"/>
             <a:r>
-              <a:rPr lang="en-US"/>
+              <a:rPr lang="en-US" smtClean="0"/>
               <a:t>Third level</a:t>
             </a:r>
           </a:p>
           <a:p>
             <a:pPr lvl="3"/>
             <a:r>
-              <a:rPr lang="en-US"/>
+              <a:rPr lang="en-US" smtClean="0"/>
               <a:t>Fourth level</a:t>
             </a:r>
           </a:p>
           <a:p>
             <a:pPr lvl="4"/>
             <a:r>
-              <a:rPr lang="en-US"/>
+              <a:rPr lang="en-US" smtClean="0"/>
               <a:t>Fifth level</a:t>
             </a:r>
+            <a:endParaRPr lang="en-US"/>
           </a:p>
         </p:txBody>
       </p:sp>
@@ -821,7 +813,7 @@
           <a:p>
             <a:fld id="{5BCAD085-E8A6-8845-BD4E-CB4CCA059FC4}" type="datetimeFigureOut">
               <a:rPr lang="en-US" smtClean="0"/>
-              <a:t>8/12/2026</a:t>
+              <a:t>1/27/13</a:t>
             </a:fld>
             <a:endParaRPr lang="en-US"/>
           </a:p>
@@ -924,9 +916,10 @@
           </a:lstStyle>
           <a:p>
             <a:r>
-              <a:rPr lang="en-US"/>
+              <a:rPr lang="en-US" smtClean="0"/>
               <a:t>Click to edit Master title style</a:t>
             </a:r>
+            <a:endParaRPr lang="en-US"/>
           </a:p>
         </p:txBody>
       </p:sp>
@@ -1043,7 +1036,7 @@
           <a:p>
             <a:pPr lvl="0"/>
             <a:r>
-              <a:rPr lang="en-US"/>
+              <a:rPr lang="en-US" smtClean="0"/>
               <a:t>Click to edit Master text styles</a:t>
             </a:r>
           </a:p>
@@ -1066,7 +1059,7 @@
           <a:p>
             <a:fld id="{5BCAD085-E8A6-8845-BD4E-CB4CCA059FC4}" type="datetimeFigureOut">
               <a:rPr lang="en-US" smtClean="0"/>
-              <a:t>8/12/2026</a:t>
+              <a:t>1/27/13</a:t>
             </a:fld>
             <a:endParaRPr lang="en-US"/>
           </a:p>
@@ -1160,9 +1153,10 @@
           <a:lstStyle/>
           <a:p>
             <a:r>
-              <a:rPr lang="en-US"/>
+              <a:rPr lang="en-US" smtClean="0"/>
               <a:t>Click to edit Master title style</a:t>
             </a:r>
+            <a:endParaRPr lang="en-US"/>
           </a:p>
         </p:txBody>
       </p:sp>
@@ -1216,37 +1210,38 @@
           <a:p>
             <a:pPr lvl="0"/>
             <a:r>
-              <a:rPr lang="en-US"/>
+              <a:rPr lang="en-US" smtClean="0"/>
               <a:t>Click to edit Master text styles</a:t>
             </a:r>
           </a:p>
           <a:p>
             <a:pPr lvl="1"/>
             <a:r>
-              <a:rPr lang="en-US"/>
+              <a:rPr lang="en-US" smtClean="0"/>
               <a:t>Second level</a:t>
             </a:r>
           </a:p>
           <a:p>
             <a:pPr lvl="2"/>
             <a:r>
-              <a:rPr lang="en-US"/>
+              <a:rPr lang="en-US" smtClean="0"/>
               <a:t>Third level</a:t>
             </a:r>
           </a:p>
           <a:p>
             <a:pPr lvl="3"/>
             <a:r>
-              <a:rPr lang="en-US"/>
+              <a:rPr lang="en-US" smtClean="0"/>
               <a:t>Fourth level</a:t>
             </a:r>
           </a:p>
           <a:p>
             <a:pPr lvl="4"/>
             <a:r>
-              <a:rPr lang="en-US"/>
+              <a:rPr lang="en-US" smtClean="0"/>
               <a:t>Fifth level</a:t>
             </a:r>
+            <a:endParaRPr lang="en-US"/>
           </a:p>
         </p:txBody>
       </p:sp>
@@ -1300,37 +1295,38 @@
           <a:p>
             <a:pPr lvl="0"/>
             <a:r>
-              <a:rPr lang="en-US"/>
+              <a:rPr lang="en-US" smtClean="0"/>
               <a:t>Click to edit Master text styles</a:t>
             </a:r>
           </a:p>
           <a:p>
             <a:pPr lvl="1"/>
             <a:r>
-              <a:rPr lang="en-US"/>
+              <a:rPr lang="en-US" smtClean="0"/>
               <a:t>Second level</a:t>
             </a:r>
           </a:p>
           <a:p>
             <a:pPr lvl="2"/>
             <a:r>
-              <a:rPr lang="en-US"/>
+              <a:rPr lang="en-US" smtClean="0"/>
               <a:t>Third level</a:t>
             </a:r>
           </a:p>
           <a:p>
             <a:pPr lvl="3"/>
             <a:r>
-              <a:rPr lang="en-US"/>
+              <a:rPr lang="en-US" smtClean="0"/>
               <a:t>Fourth level</a:t>
             </a:r>
           </a:p>
           <a:p>
             <a:pPr lvl="4"/>
             <a:r>
-              <a:rPr lang="en-US"/>
+              <a:rPr lang="en-US" smtClean="0"/>
               <a:t>Fifth level</a:t>
             </a:r>
+            <a:endParaRPr lang="en-US"/>
           </a:p>
         </p:txBody>
       </p:sp>
@@ -1351,7 +1347,7 @@
           <a:p>
             <a:fld id="{5BCAD085-E8A6-8845-BD4E-CB4CCA059FC4}" type="datetimeFigureOut">
               <a:rPr lang="en-US" smtClean="0"/>
-              <a:t>8/12/2026</a:t>
+              <a:t>1/27/13</a:t>
             </a:fld>
             <a:endParaRPr lang="en-US"/>
           </a:p>
@@ -1449,9 +1445,10 @@
           </a:lstStyle>
           <a:p>
             <a:r>
-              <a:rPr lang="en-US"/>
+              <a:rPr lang="en-US" smtClean="0"/>
               <a:t>Click to edit Master title style</a:t>
             </a:r>
+            <a:endParaRPr lang="en-US"/>
           </a:p>
         </p:txBody>
       </p:sp>
@@ -1514,7 +1511,7 @@
           <a:p>
             <a:pPr lvl="0"/>
             <a:r>
-              <a:rPr lang="en-US"/>
+              <a:rPr lang="en-US" smtClean="0"/>
               <a:t>Click to edit Master text styles</a:t>
             </a:r>
           </a:p>
@@ -1570,37 +1567,38 @@
           <a:p>
             <a:pPr lvl="0"/>
             <a:r>
-              <a:rPr lang="en-US"/>
+              <a:rPr lang="en-US" smtClean="0"/>
               <a:t>Click to edit Master text styles</a:t>
             </a:r>
           </a:p>
           <a:p>
             <a:pPr lvl="1"/>
             <a:r>
-              <a:rPr lang="en-US"/>
+              <a:rPr lang="en-US" smtClean="0"/>
               <a:t>Second level</a:t>
             </a:r>
           </a:p>
           <a:p>
             <a:pPr lvl="2"/>
             <a:r>
-              <a:rPr lang="en-US"/>
+              <a:rPr lang="en-US" smtClean="0"/>
               <a:t>Third level</a:t>
             </a:r>
           </a:p>
           <a:p>
             <a:pPr lvl="3"/>
             <a:r>
-              <a:rPr lang="en-US"/>
+              <a:rPr lang="en-US" smtClean="0"/>
               <a:t>Fourth level</a:t>
             </a:r>
           </a:p>
           <a:p>
             <a:pPr lvl="4"/>
             <a:r>
-              <a:rPr lang="en-US"/>
+              <a:rPr lang="en-US" smtClean="0"/>
               <a:t>Fifth level</a:t>
             </a:r>
+            <a:endParaRPr lang="en-US"/>
           </a:p>
         </p:txBody>
       </p:sp>
@@ -1663,7 +1661,7 @@
           <a:p>
             <a:pPr lvl="0"/>
             <a:r>
-              <a:rPr lang="en-US"/>
+              <a:rPr lang="en-US" smtClean="0"/>
               <a:t>Click to edit Master text styles</a:t>
             </a:r>
           </a:p>
@@ -1719,37 +1717,38 @@
           <a:p>
             <a:pPr lvl="0"/>
             <a:r>
-              <a:rPr lang="en-US"/>
+              <a:rPr lang="en-US" smtClean="0"/>
               <a:t>Click to edit Master text styles</a:t>
             </a:r>
           </a:p>
           <a:p>
             <a:pPr lvl="1"/>
             <a:r>
-              <a:rPr lang="en-US"/>
+              <a:rPr lang="en-US" smtClean="0"/>
               <a:t>Second level</a:t>
             </a:r>
           </a:p>
           <a:p>
             <a:pPr lvl="2"/>
             <a:r>
-              <a:rPr lang="en-US"/>
+              <a:rPr lang="en-US" smtClean="0"/>
               <a:t>Third level</a:t>
             </a:r>
           </a:p>
           <a:p>
             <a:pPr lvl="3"/>
             <a:r>
-              <a:rPr lang="en-US"/>
+              <a:rPr lang="en-US" smtClean="0"/>
               <a:t>Fourth level</a:t>
             </a:r>
           </a:p>
           <a:p>
             <a:pPr lvl="4"/>
             <a:r>
-              <a:rPr lang="en-US"/>
+              <a:rPr lang="en-US" smtClean="0"/>
               <a:t>Fifth level</a:t>
             </a:r>
+            <a:endParaRPr lang="en-US"/>
           </a:p>
         </p:txBody>
       </p:sp>
@@ -1770,7 +1769,7 @@
           <a:p>
             <a:fld id="{5BCAD085-E8A6-8845-BD4E-CB4CCA059FC4}" type="datetimeFigureOut">
               <a:rPr lang="en-US" smtClean="0"/>
-              <a:t>8/12/2026</a:t>
+              <a:t>1/27/13</a:t>
             </a:fld>
             <a:endParaRPr lang="en-US"/>
           </a:p>
@@ -1864,9 +1863,10 @@
           <a:lstStyle/>
           <a:p>
             <a:r>
-              <a:rPr lang="en-US"/>
+              <a:rPr lang="en-US" smtClean="0"/>
               <a:t>Click to edit Master title style</a:t>
             </a:r>
+            <a:endParaRPr lang="en-US"/>
           </a:p>
         </p:txBody>
       </p:sp>
@@ -1887,7 +1887,7 @@
           <a:p>
             <a:fld id="{5BCAD085-E8A6-8845-BD4E-CB4CCA059FC4}" type="datetimeFigureOut">
               <a:rPr lang="en-US" smtClean="0"/>
-              <a:t>8/12/2026</a:t>
+              <a:t>1/27/13</a:t>
             </a:fld>
             <a:endParaRPr lang="en-US"/>
           </a:p>
@@ -1982,7 +1982,7 @@
           <a:p>
             <a:fld id="{5BCAD085-E8A6-8845-BD4E-CB4CCA059FC4}" type="datetimeFigureOut">
               <a:rPr lang="en-US" smtClean="0"/>
-              <a:t>8/12/2026</a:t>
+              <a:t>1/27/13</a:t>
             </a:fld>
             <a:endParaRPr lang="en-US"/>
           </a:p>
@@ -2085,9 +2085,10 @@
           </a:lstStyle>
           <a:p>
             <a:r>
-              <a:rPr lang="en-US"/>
+              <a:rPr lang="en-US" smtClean="0"/>
               <a:t>Click to edit Master title style</a:t>
             </a:r>
+            <a:endParaRPr lang="en-US"/>
           </a:p>
         </p:txBody>
       </p:sp>
@@ -2141,37 +2142,38 @@
           <a:p>
             <a:pPr lvl="0"/>
             <a:r>
-              <a:rPr lang="en-US"/>
+              <a:rPr lang="en-US" smtClean="0"/>
               <a:t>Click to edit Master text styles</a:t>
             </a:r>
           </a:p>
           <a:p>
             <a:pPr lvl="1"/>
             <a:r>
-              <a:rPr lang="en-US"/>
+              <a:rPr lang="en-US" smtClean="0"/>
               <a:t>Second level</a:t>
             </a:r>
           </a:p>
           <a:p>
             <a:pPr lvl="2"/>
             <a:r>
-              <a:rPr lang="en-US"/>
+              <a:rPr lang="en-US" smtClean="0"/>
               <a:t>Third level</a:t>
             </a:r>
           </a:p>
           <a:p>
             <a:pPr lvl="3"/>
             <a:r>
-              <a:rPr lang="en-US"/>
+              <a:rPr lang="en-US" smtClean="0"/>
               <a:t>Fourth level</a:t>
             </a:r>
           </a:p>
           <a:p>
             <a:pPr lvl="4"/>
             <a:r>
-              <a:rPr lang="en-US"/>
+              <a:rPr lang="en-US" smtClean="0"/>
               <a:t>Fifth level</a:t>
             </a:r>
+            <a:endParaRPr lang="en-US"/>
           </a:p>
         </p:txBody>
       </p:sp>
@@ -2234,7 +2236,7 @@
           <a:p>
             <a:pPr lvl="0"/>
             <a:r>
-              <a:rPr lang="en-US"/>
+              <a:rPr lang="en-US" smtClean="0"/>
               <a:t>Click to edit Master text styles</a:t>
             </a:r>
           </a:p>
@@ -2257,7 +2259,7 @@
           <a:p>
             <a:fld id="{5BCAD085-E8A6-8845-BD4E-CB4CCA059FC4}" type="datetimeFigureOut">
               <a:rPr lang="en-US" smtClean="0"/>
-              <a:t>8/12/2026</a:t>
+              <a:t>1/27/13</a:t>
             </a:fld>
             <a:endParaRPr lang="en-US"/>
           </a:p>
@@ -2360,9 +2362,10 @@
           </a:lstStyle>
           <a:p>
             <a:r>
-              <a:rPr lang="en-US"/>
+              <a:rPr lang="en-US" smtClean="0"/>
               <a:t>Click to edit Master title style</a:t>
             </a:r>
+            <a:endParaRPr lang="en-US"/>
           </a:p>
         </p:txBody>
       </p:sp>
@@ -2486,7 +2489,7 @@
           <a:p>
             <a:pPr lvl="0"/>
             <a:r>
-              <a:rPr lang="en-US"/>
+              <a:rPr lang="en-US" smtClean="0"/>
               <a:t>Click to edit Master text styles</a:t>
             </a:r>
           </a:p>
@@ -2509,7 +2512,7 @@
           <a:p>
             <a:fld id="{5BCAD085-E8A6-8845-BD4E-CB4CCA059FC4}" type="datetimeFigureOut">
               <a:rPr lang="en-US" smtClean="0"/>
-              <a:t>8/12/2026</a:t>
+              <a:t>1/27/13</a:t>
             </a:fld>
             <a:endParaRPr lang="en-US"/>
           </a:p>
@@ -2618,9 +2621,10 @@
           <a:lstStyle/>
           <a:p>
             <a:r>
-              <a:rPr lang="en-US"/>
+              <a:rPr lang="en-US" smtClean="0"/>
               <a:t>Click to edit Master title style</a:t>
             </a:r>
+            <a:endParaRPr lang="en-US"/>
           </a:p>
         </p:txBody>
       </p:sp>
@@ -2651,37 +2655,38 @@
           <a:p>
             <a:pPr lvl="0"/>
             <a:r>
-              <a:rPr lang="en-US"/>
+              <a:rPr lang="en-US" smtClean="0"/>
               <a:t>Click to edit Master text styles</a:t>
             </a:r>
           </a:p>
           <a:p>
             <a:pPr lvl="1"/>
             <a:r>
-              <a:rPr lang="en-US"/>
+              <a:rPr lang="en-US" smtClean="0"/>
               <a:t>Second level</a:t>
             </a:r>
           </a:p>
           <a:p>
             <a:pPr lvl="2"/>
             <a:r>
-              <a:rPr lang="en-US"/>
+              <a:rPr lang="en-US" smtClean="0"/>
               <a:t>Third level</a:t>
             </a:r>
           </a:p>
           <a:p>
             <a:pPr lvl="3"/>
             <a:r>
-              <a:rPr lang="en-US"/>
+              <a:rPr lang="en-US" smtClean="0"/>
               <a:t>Fourth level</a:t>
             </a:r>
           </a:p>
           <a:p>
             <a:pPr lvl="4"/>
             <a:r>
-              <a:rPr lang="en-US"/>
+              <a:rPr lang="en-US" smtClean="0"/>
               <a:t>Fifth level</a:t>
             </a:r>
+            <a:endParaRPr lang="en-US"/>
           </a:p>
         </p:txBody>
       </p:sp>
@@ -2720,7 +2725,7 @@
           <a:p>
             <a:fld id="{5BCAD085-E8A6-8845-BD4E-CB4CCA059FC4}" type="datetimeFigureOut">
               <a:rPr lang="en-US" smtClean="0"/>
-              <a:t>8/12/2026</a:t>
+              <a:t>1/27/13</a:t>
             </a:fld>
             <a:endParaRPr lang="en-US"/>
           </a:p>
@@ -3079,7 +3084,7 @@
 </file>
 
 <file path=ppt/slides/slide1.xml><?xml version="1.0" encoding="utf-8"?>
-<p:sld xmlns:a="http://schemas.openxmlformats.org/drawingml/2006/main" xmlns:r="http://schemas.openxmlformats.org/officeDocument/2006/relationships" xmlns:p="http://schemas.openxmlformats.org/presentationml/2006/main">
+<p:sld xmlns:a="http://schemas.openxmlformats.org/drawingml/2006/main" xmlns:p="http://schemas.openxmlformats.org/presentationml/2006/main" xmlns:r="http://schemas.openxmlformats.org/officeDocument/2006/relationships">
   <p:cSld>
     <p:bg>
       <p:bgPr>
@@ -3095,14 +3100,7 @@
         <p:cNvGrpSpPr/>
         <p:nvPr/>
       </p:nvGrpSpPr>
-      <p:grpSpPr>
-        <a:xfrm>
-          <a:off x="0" y="0"/>
-          <a:ext cx="0" cy="0"/>
-          <a:chOff x="0" y="0"/>
-          <a:chExt cx="0" cy="0"/>
-        </a:xfrm>
-      </p:grpSpPr>
+      <p:grpSpPr/>
       <p:sp>
         <p:nvSpPr>
           <p:cNvPr id="2" name="Rounded Rectangle 1"/>
@@ -3145,7 +3143,6 @@
           <a:lstStyle/>
           <a:p>
             <a:pPr algn="ctr"/>
-            <a:endParaRPr/>
           </a:p>
         </p:txBody>
       </p:sp>
@@ -3280,7 +3277,6 @@
           <a:lstStyle/>
           <a:p>
             <a:pPr algn="ctr"/>
-            <a:endParaRPr/>
           </a:p>
         </p:txBody>
       </p:sp>
@@ -3365,7 +3361,6 @@
           <a:lstStyle/>
           <a:p>
             <a:pPr algn="ctr"/>
-            <a:endParaRPr/>
           </a:p>
         </p:txBody>
       </p:sp>
@@ -3577,7 +3572,7 @@
 </file>
 
 <file path=ppt/slides/slide2.xml><?xml version="1.0" encoding="utf-8"?>
-<p:sld xmlns:a="http://schemas.openxmlformats.org/drawingml/2006/main" xmlns:r="http://schemas.openxmlformats.org/officeDocument/2006/relationships" xmlns:p="http://schemas.openxmlformats.org/presentationml/2006/main">
+<p:sld xmlns:a="http://schemas.openxmlformats.org/drawingml/2006/main" xmlns:p="http://schemas.openxmlformats.org/presentationml/2006/main" xmlns:r="http://schemas.openxmlformats.org/officeDocument/2006/relationships">
   <p:cSld>
     <p:bg>
       <p:bgPr>
@@ -3593,14 +3588,7 @@
         <p:cNvGrpSpPr/>
         <p:nvPr/>
       </p:nvGrpSpPr>
-      <p:grpSpPr>
-        <a:xfrm>
-          <a:off x="0" y="0"/>
-          <a:ext cx="0" cy="0"/>
-          <a:chOff x="0" y="0"/>
-          <a:chExt cx="0" cy="0"/>
-        </a:xfrm>
-      </p:grpSpPr>
+      <p:grpSpPr/>
       <p:sp>
         <p:nvSpPr>
           <p:cNvPr id="2" name="Rounded Rectangle 1"/>
@@ -3643,7 +3631,6 @@
           <a:lstStyle/>
           <a:p>
             <a:pPr algn="ctr"/>
-            <a:endParaRPr/>
           </a:p>
         </p:txBody>
       </p:sp>
@@ -3761,7 +3748,6 @@
           <a:lstStyle/>
           <a:p>
             <a:pPr algn="ctr"/>
-            <a:endParaRPr/>
           </a:p>
         </p:txBody>
       </p:sp>
@@ -3910,7 +3896,6 @@
           <a:lstStyle/>
           <a:p>
             <a:pPr algn="ctr"/>
-            <a:endParaRPr/>
           </a:p>
         </p:txBody>
       </p:sp>
@@ -4050,7 +4035,7 @@
 </file>
 
 <file path=ppt/slides/slide3.xml><?xml version="1.0" encoding="utf-8"?>
-<p:sld xmlns:a="http://schemas.openxmlformats.org/drawingml/2006/main" xmlns:r="http://schemas.openxmlformats.org/officeDocument/2006/relationships" xmlns:p="http://schemas.openxmlformats.org/presentationml/2006/main">
+<p:sld xmlns:a="http://schemas.openxmlformats.org/drawingml/2006/main" xmlns:p="http://schemas.openxmlformats.org/presentationml/2006/main" xmlns:r="http://schemas.openxmlformats.org/officeDocument/2006/relationships">
   <p:cSld>
     <p:bg>
       <p:bgPr>
@@ -4066,14 +4051,7 @@
         <p:cNvGrpSpPr/>
         <p:nvPr/>
       </p:nvGrpSpPr>
-      <p:grpSpPr>
-        <a:xfrm>
-          <a:off x="0" y="0"/>
-          <a:ext cx="0" cy="0"/>
-          <a:chOff x="0" y="0"/>
-          <a:chExt cx="0" cy="0"/>
-        </a:xfrm>
-      </p:grpSpPr>
+      <p:grpSpPr/>
       <p:sp>
         <p:nvSpPr>
           <p:cNvPr id="2" name="Rounded Rectangle 1"/>
@@ -4116,7 +4094,6 @@
           <a:lstStyle/>
           <a:p>
             <a:pPr algn="ctr"/>
-            <a:endParaRPr/>
           </a:p>
         </p:txBody>
       </p:sp>
@@ -4232,7 +4209,6 @@
           <a:lstStyle/>
           <a:p>
             <a:pPr algn="ctr"/>
-            <a:endParaRPr/>
           </a:p>
         </p:txBody>
       </p:sp>
@@ -4333,7 +4309,6 @@
           <a:lstStyle/>
           <a:p>
             <a:pPr algn="ctr"/>
-            <a:endParaRPr/>
           </a:p>
         </p:txBody>
       </p:sp>
@@ -4466,7 +4441,6 @@
           <a:lstStyle/>
           <a:p>
             <a:pPr algn="ctr"/>
-            <a:endParaRPr/>
           </a:p>
         </p:txBody>
       </p:sp>
@@ -4583,7 +4557,6 @@
           <a:lstStyle/>
           <a:p>
             <a:pPr algn="ctr"/>
-            <a:endParaRPr/>
           </a:p>
         </p:txBody>
       </p:sp>
@@ -4716,7 +4689,6 @@
           <a:lstStyle/>
           <a:p>
             <a:pPr algn="ctr"/>
-            <a:endParaRPr/>
           </a:p>
         </p:txBody>
       </p:sp>
@@ -4928,7 +4900,7 @@
 </file>
 
 <file path=ppt/slides/slide4.xml><?xml version="1.0" encoding="utf-8"?>
-<p:sld xmlns:a="http://schemas.openxmlformats.org/drawingml/2006/main" xmlns:r="http://schemas.openxmlformats.org/officeDocument/2006/relationships" xmlns:p="http://schemas.openxmlformats.org/presentationml/2006/main">
+<p:sld xmlns:a="http://schemas.openxmlformats.org/drawingml/2006/main" xmlns:p="http://schemas.openxmlformats.org/presentationml/2006/main" xmlns:r="http://schemas.openxmlformats.org/officeDocument/2006/relationships">
   <p:cSld>
     <p:bg>
       <p:bgPr>
@@ -4944,14 +4916,7 @@
         <p:cNvGrpSpPr/>
         <p:nvPr/>
       </p:nvGrpSpPr>
-      <p:grpSpPr>
-        <a:xfrm>
-          <a:off x="0" y="0"/>
-          <a:ext cx="0" cy="0"/>
-          <a:chOff x="0" y="0"/>
-          <a:chExt cx="0" cy="0"/>
-        </a:xfrm>
-      </p:grpSpPr>
+      <p:grpSpPr/>
       <p:sp>
         <p:nvSpPr>
           <p:cNvPr id="2" name="Rounded Rectangle 1"/>
@@ -4994,7 +4959,6 @@
           <a:lstStyle/>
           <a:p>
             <a:pPr algn="ctr"/>
-            <a:endParaRPr/>
           </a:p>
         </p:txBody>
       </p:sp>
@@ -5112,7 +5076,6 @@
           <a:lstStyle/>
           <a:p>
             <a:pPr algn="ctr"/>
-            <a:endParaRPr/>
           </a:p>
         </p:txBody>
       </p:sp>
@@ -5317,7 +5280,6 @@
           <a:lstStyle/>
           <a:p>
             <a:pPr algn="ctr"/>
-            <a:endParaRPr/>
           </a:p>
         </p:txBody>
       </p:sp>
@@ -5513,7 +5475,7 @@
 </file>
 
 <file path=ppt/slides/slide5.xml><?xml version="1.0" encoding="utf-8"?>
-<p:sld xmlns:a="http://schemas.openxmlformats.org/drawingml/2006/main" xmlns:r="http://schemas.openxmlformats.org/officeDocument/2006/relationships" xmlns:p="http://schemas.openxmlformats.org/presentationml/2006/main">
+<p:sld xmlns:a="http://schemas.openxmlformats.org/drawingml/2006/main" xmlns:p="http://schemas.openxmlformats.org/presentationml/2006/main" xmlns:r="http://schemas.openxmlformats.org/officeDocument/2006/relationships">
   <p:cSld>
     <p:bg>
       <p:bgPr>
@@ -5529,14 +5491,7 @@
         <p:cNvGrpSpPr/>
         <p:nvPr/>
       </p:nvGrpSpPr>
-      <p:grpSpPr>
-        <a:xfrm>
-          <a:off x="0" y="0"/>
-          <a:ext cx="0" cy="0"/>
-          <a:chOff x="0" y="0"/>
-          <a:chExt cx="0" cy="0"/>
-        </a:xfrm>
-      </p:grpSpPr>
+      <p:grpSpPr/>
       <p:sp>
         <p:nvSpPr>
           <p:cNvPr id="2" name="Rounded Rectangle 1"/>
@@ -5579,7 +5534,6 @@
           <a:lstStyle/>
           <a:p>
             <a:pPr algn="ctr"/>
-            <a:endParaRPr/>
           </a:p>
         </p:txBody>
       </p:sp>
@@ -5697,7 +5651,6 @@
           <a:lstStyle/>
           <a:p>
             <a:pPr algn="ctr"/>
-            <a:endParaRPr/>
           </a:p>
         </p:txBody>
       </p:sp>
@@ -5934,7 +5887,6 @@
           <a:lstStyle/>
           <a:p>
             <a:pPr algn="ctr"/>
-            <a:endParaRPr/>
           </a:p>
         </p:txBody>
       </p:sp>
@@ -5996,34 +5948,10 @@
                 <a:tableStyleId>{5C22544A-7EE6-4342-B048-85BDC9FD1C3A}</a:tableStyleId>
               </a:tblPr>
               <a:tblGrid>
-                <a:gridCol w="1257300">
-                  <a:extLst>
-                    <a:ext uri="{9D8B030D-6E8A-4147-A177-3AD203B41FA5}">
-                      <a16:colId xmlns:a16="http://schemas.microsoft.com/office/drawing/2014/main" val="20000"/>
-                    </a:ext>
-                  </a:extLst>
-                </a:gridCol>
-                <a:gridCol w="1257300">
-                  <a:extLst>
-                    <a:ext uri="{9D8B030D-6E8A-4147-A177-3AD203B41FA5}">
-                      <a16:colId xmlns:a16="http://schemas.microsoft.com/office/drawing/2014/main" val="20001"/>
-                    </a:ext>
-                  </a:extLst>
-                </a:gridCol>
-                <a:gridCol w="1257300">
-                  <a:extLst>
-                    <a:ext uri="{9D8B030D-6E8A-4147-A177-3AD203B41FA5}">
-                      <a16:colId xmlns:a16="http://schemas.microsoft.com/office/drawing/2014/main" val="20002"/>
-                    </a:ext>
-                  </a:extLst>
-                </a:gridCol>
-                <a:gridCol w="1257300">
-                  <a:extLst>
-                    <a:ext uri="{9D8B030D-6E8A-4147-A177-3AD203B41FA5}">
-                      <a16:colId xmlns:a16="http://schemas.microsoft.com/office/drawing/2014/main" val="20003"/>
-                    </a:ext>
-                  </a:extLst>
-                </a:gridCol>
+                <a:gridCol w="1257300"/>
+                <a:gridCol w="1257300"/>
+                <a:gridCol w="1257300"/>
+                <a:gridCol w="1257300"/>
               </a:tblGrid>
               <a:tr h="548640">
                 <a:tc>
@@ -6122,11 +6050,6 @@
                     </a:solidFill>
                   </a:tcPr>
                 </a:tc>
-                <a:extLst>
-                  <a:ext uri="{0D108BD9-81ED-4DB2-BD59-A6C34878D82A}">
-                    <a16:rowId xmlns:a16="http://schemas.microsoft.com/office/drawing/2014/main" val="10000"/>
-                  </a:ext>
-                </a:extLst>
               </a:tr>
               <a:tr h="548640">
                 <a:tc>
@@ -6225,11 +6148,6 @@
                     </a:solidFill>
                   </a:tcPr>
                 </a:tc>
-                <a:extLst>
-                  <a:ext uri="{0D108BD9-81ED-4DB2-BD59-A6C34878D82A}">
-                    <a16:rowId xmlns:a16="http://schemas.microsoft.com/office/drawing/2014/main" val="10001"/>
-                  </a:ext>
-                </a:extLst>
               </a:tr>
               <a:tr h="548640">
                 <a:tc>
@@ -6328,11 +6246,6 @@
                     </a:solidFill>
                   </a:tcPr>
                 </a:tc>
-                <a:extLst>
-                  <a:ext uri="{0D108BD9-81ED-4DB2-BD59-A6C34878D82A}">
-                    <a16:rowId xmlns:a16="http://schemas.microsoft.com/office/drawing/2014/main" val="10002"/>
-                  </a:ext>
-                </a:extLst>
               </a:tr>
               <a:tr h="548640">
                 <a:tc>
@@ -6431,11 +6344,6 @@
                     </a:solidFill>
                   </a:tcPr>
                 </a:tc>
-                <a:extLst>
-                  <a:ext uri="{0D108BD9-81ED-4DB2-BD59-A6C34878D82A}">
-                    <a16:rowId xmlns:a16="http://schemas.microsoft.com/office/drawing/2014/main" val="10003"/>
-                  </a:ext>
-                </a:extLst>
               </a:tr>
               <a:tr h="548640">
                 <a:tc>
@@ -6534,11 +6442,6 @@
                     </a:solidFill>
                   </a:tcPr>
                 </a:tc>
-                <a:extLst>
-                  <a:ext uri="{0D108BD9-81ED-4DB2-BD59-A6C34878D82A}">
-                    <a16:rowId xmlns:a16="http://schemas.microsoft.com/office/drawing/2014/main" val="10004"/>
-                  </a:ext>
-                </a:extLst>
               </a:tr>
               <a:tr h="548640">
                 <a:tc>
@@ -6637,11 +6540,6 @@
                     </a:solidFill>
                   </a:tcPr>
                 </a:tc>
-                <a:extLst>
-                  <a:ext uri="{0D108BD9-81ED-4DB2-BD59-A6C34878D82A}">
-                    <a16:rowId xmlns:a16="http://schemas.microsoft.com/office/drawing/2014/main" val="10005"/>
-                  </a:ext>
-                </a:extLst>
               </a:tr>
               <a:tr h="548640">
                 <a:tc>
@@ -6740,11 +6638,6 @@
                     </a:solidFill>
                   </a:tcPr>
                 </a:tc>
-                <a:extLst>
-                  <a:ext uri="{0D108BD9-81ED-4DB2-BD59-A6C34878D82A}">
-                    <a16:rowId xmlns:a16="http://schemas.microsoft.com/office/drawing/2014/main" val="10006"/>
-                  </a:ext>
-                </a:extLst>
               </a:tr>
             </a:tbl>
           </a:graphicData>
@@ -6759,7 +6652,7 @@
 </file>
 
 <file path=ppt/slides/slide6.xml><?xml version="1.0" encoding="utf-8"?>
-<p:sld xmlns:a="http://schemas.openxmlformats.org/drawingml/2006/main" xmlns:r="http://schemas.openxmlformats.org/officeDocument/2006/relationships" xmlns:p="http://schemas.openxmlformats.org/presentationml/2006/main">
+<p:sld xmlns:a="http://schemas.openxmlformats.org/drawingml/2006/main" xmlns:p="http://schemas.openxmlformats.org/presentationml/2006/main" xmlns:r="http://schemas.openxmlformats.org/officeDocument/2006/relationships">
   <p:cSld>
     <p:bg>
       <p:bgPr>
@@ -6775,14 +6668,7 @@
         <p:cNvGrpSpPr/>
         <p:nvPr/>
       </p:nvGrpSpPr>
-      <p:grpSpPr>
-        <a:xfrm>
-          <a:off x="0" y="0"/>
-          <a:ext cx="0" cy="0"/>
-          <a:chOff x="0" y="0"/>
-          <a:chExt cx="0" cy="0"/>
-        </a:xfrm>
-      </p:grpSpPr>
+      <p:grpSpPr/>
       <p:sp>
         <p:nvSpPr>
           <p:cNvPr id="2" name="Rounded Rectangle 1"/>
@@ -6825,7 +6711,6 @@
           <a:lstStyle/>
           <a:p>
             <a:pPr algn="ctr"/>
-            <a:endParaRPr/>
           </a:p>
         </p:txBody>
       </p:sp>
@@ -6943,7 +6828,6 @@
           <a:lstStyle/>
           <a:p>
             <a:pPr algn="ctr"/>
-            <a:endParaRPr/>
           </a:p>
         </p:txBody>
       </p:sp>
@@ -7172,7 +7056,6 @@
           <a:lstStyle/>
           <a:p>
             <a:pPr algn="ctr"/>
-            <a:endParaRPr/>
           </a:p>
         </p:txBody>
       </p:sp>

</xml_diff>